<commit_message>
Refine DAS layout and add wall-aware coverage scenarios
Select a 32-antenna layout, document the assumed equipment location, and update cable routes, equipment quantities, and presentation. Add reproducible coverage maps and sensitivity scenarios with explicit assumptions and KPI limitations.
</commit_message>
<xml_diff>
--- a/presentation/defense-draft.pptx
+++ b/presentation/defense-draft.pptx
@@ -4224,7 +4224,7 @@
               <a:defRPr sz="2000"/>
             </a:pPr>
             <a:r>
-              <a:t>48 In06: рабочий вариант для проверки</a:t>
+              <a:t>32 In06: схема после расчётного сравнения</a:t>
             </a:r>
           </a:p>
           <a:p>
@@ -4246,7 +4246,7 @@
               <a:defRPr sz="2000"/>
             </a:pPr>
             <a:r>
-              <a:t>ВК не найдена: точка ввода требует согласования</a:t>
+              <a:t>Проектная ВК: часть 104.2; собственное допущение</a:t>
             </a:r>
           </a:p>
           <a:p>
@@ -4376,7 +4376,7 @@
               <a:defRPr sz="2000"/>
             </a:pPr>
             <a:r>
-              <a:t>Контрольные точки: 5 / 10 / 15 / 20 м</a:t>
+              <a:t>384 RF-точек и 35007 ячеек карты; шаг 0.25 м</a:t>
             </a:r>
           </a:p>
           <a:p>
@@ -4387,7 +4387,7 @@
               <a:defRPr sz="2000"/>
             </a:pPr>
             <a:r>
-              <a:t>Пилот 23 дБм: несколько возможных нормировок</a:t>
+              <a:t>P1, n=2,5, стены/колонны: B3/B1/B7 — 95.78%/95.78%/95.77%</a:t>
             </a:r>
           </a:p>
           <a:p>
@@ -4398,7 +4398,7 @@
               <a:defRPr sz="2000"/>
             </a:pPr>
             <a:r>
-              <a:t>Худшая ветвь кандидата: 31.0 дБ RF-потерь</a:t>
+              <a:t>B7 с дополнительными 3 дБ потерь: 93.91%</a:t>
             </a:r>
           </a:p>
           <a:p>
@@ -4409,7 +4409,7 @@
               <a:defRPr sz="2000"/>
             </a:pPr>
             <a:r>
-              <a:t>Потери стен: 15 дБ; колонн и фасада: 30 дБ</a:t>
+              <a:t>45,52 м² помещения 89 считаются непокрытыми</a:t>
             </a:r>
           </a:p>
           <a:p>
@@ -4420,7 +4420,7 @@
               <a:defRPr sz="2000"/>
             </a:pPr>
             <a:r>
-              <a:t>KPI площади и SINR ещё не подтверждены</a:t>
+              <a:t>Прогноз модели; SINR, RSRQ и фактические KPI не подтверждены</a:t>
             </a:r>
           </a:p>
         </p:txBody>
@@ -4526,7 +4526,7 @@
               <a:defRPr sz="2000"/>
             </a:pPr>
             <a:r>
-              <a:t>48 антенн; 24 PC252; 8 PC251; 8 PC211; 6 PC221; 1 PC250</a:t>
+              <a:t>32 антенн; 16 PC252; 0 PC251; 8 PC211; 6 PC221; 9 PC250</a:t>
             </a:r>
           </a:p>
           <a:p>
@@ -4537,7 +4537,7 @@
               <a:defRPr sz="2000"/>
             </a:pPr>
             <a:r>
-              <a:t>Фидеры без резерва: 1/2 — 576.6 м; 7/8 — 1272.4 м</a:t>
+              <a:t>Фидеры без резерва: 1/2 — 362.7 м; 7/8 — 721.5 м</a:t>
             </a:r>
           </a:p>
           <a:p>
@@ -4687,7 +4687,7 @@
               <a:defRPr sz="2000"/>
             </a:pPr>
             <a:r>
-              <a:t>До сдачи: ВК, помещение 89, пилот, параметры компонентов, карты KPI</a:t>
+              <a:t>Приняты допущения: ВК в 104.2, нормировка пилота, параметры компонентов и модель стен</a:t>
             </a:r>
           </a:p>
           <a:p>

</xml_diff>

<commit_message>
Restore room geometry and add 3 dB RSRP reserve
Rebuild CAD room boundaries and compare the previous layout on the same geometry. Redistribute the existing 32 antennas through unequal 2+2+4 passive branches without increasing pilot power. Verify the routed design on a 0.25 m grid and export all five deliverables. Document increased cable length and remaining propagation, KPI and equipment limitations.
</commit_message>
<xml_diff>
--- a/presentation/defense-draft.pptx
+++ b/presentation/defense-draft.pptx
@@ -4376,7 +4376,7 @@
               <a:defRPr sz="2000"/>
             </a:pPr>
             <a:r>
-              <a:t>384 RF-точек и 35007 ячеек карты; шаг 0.25 м</a:t>
+              <a:t>384 RF-точек и 35522 ячеек карты; шаг 0.25 м</a:t>
             </a:r>
           </a:p>
           <a:p>
@@ -4387,7 +4387,7 @@
               <a:defRPr sz="2000"/>
             </a:pPr>
             <a:r>
-              <a:t>P1, n=2,5, стены/колонны: B3/B1/B7 — 95.78%/95.78%/95.77%</a:t>
+              <a:t>P1, n=2,5, стены/колонны: B3/B1/B7 — 96.56%/96.55%/96.55%</a:t>
             </a:r>
           </a:p>
           <a:p>
@@ -4398,7 +4398,7 @@
               <a:defRPr sz="2000"/>
             </a:pPr>
             <a:r>
-              <a:t>B7 с дополнительными 3 дБ потерь: 93.65%</a:t>
+              <a:t>B7 с дополнительными 3 дБ потерь: 96.32%</a:t>
             </a:r>
           </a:p>
           <a:p>
@@ -4537,7 +4537,7 @@
               <a:defRPr sz="2000"/>
             </a:pPr>
             <a:r>
-              <a:t>Фидеры без резерва: 1/2 — 362.7 м; 7/8 — 721.5 м</a:t>
+              <a:t>Фидеры без резерва: 1/2 — 265.3 м; 7/8 — 1196.0 м</a:t>
             </a:r>
           </a:p>
           <a:p>

</xml_diff>

<commit_message>
Adopt verified n=3 design in final submission
Update hub locations, power classes and routed losses while keeping 32 antennas, pilot power and source geometry. Regenerate 39 LTE scenarios, equipment quantities, 14 A3 sheets and all five submission artifacts. Preserve frozen research provenance and document remaining P2 and KPI limitations.
</commit_message>
<xml_diff>
--- a/presentation/defense-draft.pptx
+++ b/presentation/defense-draft.pptx
@@ -4387,7 +4387,7 @@
               <a:defRPr sz="2000"/>
             </a:pPr>
             <a:r>
-              <a:t>P1, n=2,5, стены/колонны: B3/B1/B7 — 96.56%/96.55%/96.55%</a:t>
+              <a:t>P1, n=2,5, стены/колонны: B3/B1/B7 — 96.59%/96.58%/96.58%</a:t>
             </a:r>
           </a:p>
           <a:p>
@@ -4398,7 +4398,7 @@
               <a:defRPr sz="2000"/>
             </a:pPr>
             <a:r>
-              <a:t>B7 с дополнительными 3 дБ потерь: 96.32%</a:t>
+              <a:t>B7 с дополнительными 3 дБ потерь: 96.51%</a:t>
             </a:r>
           </a:p>
           <a:p>
@@ -4537,7 +4537,7 @@
               <a:defRPr sz="2000"/>
             </a:pPr>
             <a:r>
-              <a:t>Фидеры без резерва: 1/2 — 265.3 м; 7/8 — 1196.0 м</a:t>
+              <a:t>Фидеры без резерва: 1/2 — 162.3 м; 7/8 — 1241.4 м</a:t>
             </a:r>
           </a:p>
           <a:p>

</xml_diff>